<commit_message>
docs: populate capstone PowerPoint with project content
All 10 content slides updated: cover, project overview, AI approach
(5 phases), before/after, impact scorecard, reusability, AI right/wrong,
evidence artifacts, self-rating (69/150), and reflection.

Co-Authored-By: Claude Sonnet 4.6 <noreply@anthropic.com>
</commit_message>
<xml_diff>
--- a/docs/AI_Capstone_Template_L1 op 4.pptx
+++ b/docs/AI_Capstone_Template_L1 op 4.pptx
@@ -1856,7 +1856,7 @@
                 <a:ea typeface="Calibri"/>
                 <a:cs typeface="Calibri"/>
               </a:rPr>
-              <a:t>Submission Template — Option X</a:t>
+              <a:t>Submission - Option 2: Internal Platform Contribution</a:t>
             </a:r>
             <a:endParaRPr lang="en-US" sz="1400">
               <a:latin typeface="Calibri"/>
@@ -1933,7 +1933,7 @@
                 <a:ea typeface="Calibri" pitchFamily="34" charset="-122"/>
                 <a:cs typeface="Calibri" pitchFamily="34" charset="-120"/>
               </a:rPr>
-              <a:t>Option X — Option</a:t>
+              <a:t>Option 2 - Internal Platform Contribution</a:t>
             </a:r>
             <a:endParaRPr lang="en-US" sz="1200" dirty="0"/>
           </a:p>
@@ -2007,7 +2007,7 @@
                 <a:ea typeface="Calibri"/>
                 <a:cs typeface="Calibri"/>
               </a:rPr>
-              <a:t>Name: </a:t>
+              <a:t>Name: Julian Largor                    Date: 2026-08-10</a:t>
             </a:r>
             <a:r>
               <a:rPr lang="en-US" sz="1300" dirty="0">
@@ -2017,7 +2017,7 @@
                 <a:ea typeface="Calibri"/>
                 <a:cs typeface="Calibri"/>
               </a:rPr>
-              <a:t>______________________________     </a:t>
+              <a:t/>
             </a:r>
             <a:r>
               <a:rPr lang="en-US" sz="1300" b="1" dirty="0">
@@ -2027,7 +2027,7 @@
                 <a:ea typeface="Calibri"/>
                 <a:cs typeface="Calibri"/>
               </a:rPr>
-              <a:t>Date: </a:t>
+              <a:t/>
             </a:r>
             <a:r>
               <a:rPr lang="en-US" sz="1300" dirty="0">
@@ -2037,7 +2037,7 @@
                 <a:ea typeface="Calibri"/>
                 <a:cs typeface="Calibri"/>
               </a:rPr>
-              <a:t>____________________</a:t>
+              <a:t/>
             </a:r>
             <a:endParaRPr lang="en-US" sz="1300" dirty="0">
               <a:ea typeface="Calibri"/>
@@ -4102,7 +4102,7 @@
                 <a:ea typeface="Arial" pitchFamily="34" charset="-122"/>
                 <a:cs typeface="Arial" pitchFamily="34" charset="-120"/>
               </a:rPr>
-              <a:t>____ / 30</a:t>
+              <a:t>22 / 30</a:t>
             </a:r>
             <a:endParaRPr lang="en-US" sz="1200"/>
           </a:p>
@@ -4248,7 +4248,7 @@
                 <a:ea typeface="Arial" pitchFamily="34" charset="-122"/>
                 <a:cs typeface="Arial" pitchFamily="34" charset="-120"/>
               </a:rPr>
-              <a:t>____ / 30</a:t>
+              <a:t>24 / 30</a:t>
             </a:r>
             <a:endParaRPr lang="en-US" sz="1200"/>
           </a:p>
@@ -4394,7 +4394,7 @@
                 <a:ea typeface="Arial" pitchFamily="34" charset="-122"/>
                 <a:cs typeface="Arial" pitchFamily="34" charset="-120"/>
               </a:rPr>
-              <a:t>____ / 30</a:t>
+              <a:t>23 / 30</a:t>
             </a:r>
             <a:endParaRPr lang="en-US" sz="1200"/>
           </a:p>
@@ -4540,7 +4540,7 @@
                 <a:ea typeface="Arial" pitchFamily="34" charset="-122"/>
                 <a:cs typeface="Arial" pitchFamily="34" charset="-120"/>
               </a:rPr>
-              <a:t>____ / 30</a:t>
+              <a:t>0 / 30</a:t>
             </a:r>
             <a:endParaRPr lang="en-US" sz="1200"/>
           </a:p>
@@ -4686,7 +4686,7 @@
                 <a:ea typeface="Arial" pitchFamily="34" charset="-122"/>
                 <a:cs typeface="Arial" pitchFamily="34" charset="-120"/>
               </a:rPr>
-              <a:t>____ / 30</a:t>
+              <a:t>0 / 30</a:t>
             </a:r>
             <a:endParaRPr lang="en-US" sz="1200"/>
           </a:p>
@@ -4754,7 +4754,7 @@
                 <a:ea typeface="Arial" pitchFamily="34" charset="-122"/>
                 <a:cs typeface="Arial" pitchFamily="34" charset="-120"/>
               </a:rPr>
-              <a:t>My total:  ____ / 150</a:t>
+              <a:t>My total:  69 / 150      Clear = 70+     (I demonstrated 3 of 5 topics)</a:t>
             </a:r>
             <a:r>
               <a:rPr lang="en-US" sz="1200">
@@ -4765,7 +4765,7 @@
                 <a:ea typeface="Arial" pitchFamily="34" charset="-122"/>
                 <a:cs typeface="Arial" pitchFamily="34" charset="-120"/>
               </a:rPr>
-              <a:t>      Clear = 70+     (I demonstrated ____ of 5 topics)</a:t>
+              <a:t/>
             </a:r>
             <a:endParaRPr lang="en-US" sz="1600"/>
           </a:p>
@@ -5046,7 +5046,7 @@
                 <a:ea typeface="Calibri" pitchFamily="34" charset="-122"/>
                 <a:cs typeface="Calibri" pitchFamily="34" charset="-120"/>
               </a:rPr>
-              <a:t>"Now I know it is …"</a:t>
+              <a:t>Now I know it is a force-multiplier for mechanical, well-defined tasks - but it generates plausible-looking code that fails in edge cases the agent did not encounter during exploration. Human review is not optional.</a:t>
             </a:r>
             <a:endParaRPr lang="en-US" sz="1100"/>
           </a:p>
@@ -5158,7 +5158,7 @@
                 <a:ea typeface="Calibri" pitchFamily="34" charset="-122"/>
                 <a:cs typeface="Calibri" pitchFamily="34" charset="-120"/>
               </a:rPr>
-              <a:t>[ … ]</a:t>
+              <a:t>The agent produced working code on the first pass for 6 of 8 tests. The 2 that failed revealed a consistent pattern: AI optimizes for the conditions it observed, not the full range of conditions in production.</a:t>
             </a:r>
             <a:endParaRPr lang="en-US" sz="1100"/>
           </a:p>
@@ -5236,7 +5236,7 @@
                 <a:ea typeface="Calibri" pitchFamily="34" charset="-122"/>
                 <a:cs typeface="Calibri" pitchFamily="34" charset="-120"/>
               </a:rPr>
-              <a:t>Before: </a:t>
+              <a:t>Before: 5 /10        After: 8 /10</a:t>
             </a:r>
             <a:r>
               <a:rPr lang="en-US" sz="1300">
@@ -5247,7 +5247,7 @@
                 <a:ea typeface="Calibri" pitchFamily="34" charset="-122"/>
                 <a:cs typeface="Calibri" pitchFamily="34" charset="-120"/>
               </a:rPr>
-              <a:t>__ /10        </a:t>
+              <a:t/>
             </a:r>
             <a:r>
               <a:rPr lang="en-US" sz="1300" b="1">
@@ -5258,7 +5258,7 @@
                 <a:ea typeface="Calibri" pitchFamily="34" charset="-122"/>
                 <a:cs typeface="Calibri" pitchFamily="34" charset="-120"/>
               </a:rPr>
-              <a:t>After: </a:t>
+              <a:t/>
             </a:r>
             <a:r>
               <a:rPr lang="en-US" sz="1300">
@@ -5269,7 +5269,7 @@
                 <a:ea typeface="Calibri" pitchFamily="34" charset="-122"/>
                 <a:cs typeface="Calibri" pitchFamily="34" charset="-120"/>
               </a:rPr>
-              <a:t>__ /10</a:t>
+              <a:t/>
             </a:r>
             <a:endParaRPr lang="en-US" sz="1300"/>
           </a:p>
@@ -5381,7 +5381,7 @@
                 <a:ea typeface="Calibri" pitchFamily="34" charset="-122"/>
                 <a:cs typeface="Calibri" pitchFamily="34" charset="-120"/>
               </a:rPr>
-              <a:t>[ … ]</a:t>
+              <a:t>Give the agent a CLAUDE.md before it writes a single line. The difference in output quality is immediate and measurable - see docs/claude_md_evidence.md for a 7-point before/after comparison.</a:t>
             </a:r>
             <a:endParaRPr lang="en-US" sz="1100"/>
           </a:p>
@@ -7832,7 +7832,7 @@
                 <a:ea typeface="Calibri" pitchFamily="34" charset="-122"/>
                 <a:cs typeface="Calibri" pitchFamily="34" charset="-120"/>
               </a:rPr>
-              <a:t>[ … ]</a:t>
+              <a:t>Perficient AI Academy - QA Automation Migration Framework</a:t>
             </a:r>
             <a:endParaRPr lang="en-US" sz="1100"/>
           </a:p>
@@ -7944,7 +7944,7 @@
                 <a:ea typeface="Calibri" pitchFamily="34" charset="-122"/>
                 <a:cs typeface="Calibri" pitchFamily="34" charset="-120"/>
               </a:rPr>
-              <a:t>[ … ]</a:t>
+              <a:t>Agent-driven Cypress to Playwright migration workflow. AI agent reads requirements, explores live app via MCP Playwright, generates Cypress TS + Playwright Python BDD suites from a single requirements document. 8/8 tests passing in both frameworks.</a:t>
             </a:r>
             <a:endParaRPr lang="en-US" sz="1100"/>
           </a:p>
@@ -8056,7 +8056,7 @@
                 <a:ea typeface="Calibri" pitchFamily="34" charset="-122"/>
                 <a:cs typeface="Calibri" pitchFamily="34" charset="-120"/>
               </a:rPr>
-              <a:t>[ … ]</a:t>
+              <a:t>2-3 days of manual migration work compressed into one agent session (~7h). Reusable prompts + project structure portable to any future migration target.</a:t>
             </a:r>
             <a:endParaRPr lang="en-US" sz="1100"/>
           </a:p>
@@ -8303,7 +8303,7 @@
                 <a:ea typeface="Calibri" pitchFamily="34" charset="-122"/>
                 <a:cs typeface="Calibri" pitchFamily="34" charset="-120"/>
               </a:rPr>
-              <a:t>[ e.g., "Turn a legacy migration ticket into a reviewed, tested PR in one session." ]</a:t>
+              <a:t>Generate passing Cypress TS + Playwright Python BDD test suites from a requirements document, using MCP Playwright to verify selectors against the live app before generating any code.</a:t>
             </a:r>
             <a:endParaRPr lang="en-US" sz="1100"/>
           </a:p>
@@ -8437,7 +8437,7 @@
                 <a:ea typeface="Arial" pitchFamily="34" charset="-122"/>
                 <a:cs typeface="Arial" pitchFamily="34" charset="-120"/>
               </a:rPr>
-              <a:t>Step / Phase</a:t>
+              <a:t>Phase 1 - Requirements + Context</a:t>
             </a:r>
             <a:endParaRPr lang="en-US" sz="1100"/>
           </a:p>
@@ -8476,7 +8476,7 @@
                 <a:ea typeface="Calibri" pitchFamily="34" charset="-122"/>
                 <a:cs typeface="Calibri" pitchFamily="34" charset="-120"/>
               </a:rPr>
-              <a:t>What happens here + which AI tool / prompt you used</a:t>
+              <a:t>Define 7 functional requirements in functional_requirements_Cypress.md. Author CLAUDE.md with project conventions: naming, POM structure, credential handling, report paths. Tool: Claude Code.</a:t>
             </a:r>
             <a:endParaRPr lang="en-US" sz="950"/>
           </a:p>
@@ -8610,7 +8610,7 @@
                 <a:ea typeface="Arial" pitchFamily="34" charset="-122"/>
                 <a:cs typeface="Arial" pitchFamily="34" charset="-120"/>
               </a:rPr>
-              <a:t>Step / Phase</a:t>
+              <a:t>Phase 2 - Live App Exploration</a:t>
             </a:r>
             <a:endParaRPr lang="en-US" sz="1100"/>
           </a:p>
@@ -8649,7 +8649,7 @@
                 <a:ea typeface="Calibri" pitchFamily="34" charset="-122"/>
                 <a:cs typeface="Calibri" pitchFamily="34" charset="-120"/>
               </a:rPr>
-              <a:t>What happens here + which AI tool / prompt you used</a:t>
+              <a:t>Agent opens Chrome via MCP Playwright, navigates each requirement flow, captures real selectors and expected values from the live OrangeHRM demo. No guessing, no stale locators.</a:t>
             </a:r>
             <a:endParaRPr lang="en-US" sz="950"/>
           </a:p>
@@ -8783,7 +8783,7 @@
                 <a:ea typeface="Arial" pitchFamily="34" charset="-122"/>
                 <a:cs typeface="Arial" pitchFamily="34" charset="-120"/>
               </a:rPr>
-              <a:t>Step / Phase</a:t>
+              <a:t>Phase 3 - Cypress Generation</a:t>
             </a:r>
             <a:endParaRPr lang="en-US" sz="1100"/>
           </a:p>
@@ -8822,7 +8822,7 @@
                 <a:ea typeface="Calibri" pitchFamily="34" charset="-122"/>
                 <a:cs typeface="Calibri" pitchFamily="34" charset="-120"/>
               </a:rPr>
-              <a:t>What happens here + which AI tool / prompt you used</a:t>
+              <a:t>Agent generates TypeScript Page Objects + spec files following CLAUDE.md conventions. POM pattern, credentials via Cypress.env(), describe blocks labeled with REQ IDs. 7 specs + 6 POMs generated.</a:t>
             </a:r>
             <a:endParaRPr lang="en-US" sz="950"/>
           </a:p>
@@ -8956,7 +8956,7 @@
                 <a:ea typeface="Arial" pitchFamily="34" charset="-122"/>
                 <a:cs typeface="Arial" pitchFamily="34" charset="-120"/>
               </a:rPr>
-              <a:t>Step / Phase</a:t>
+              <a:t>Phase 4 - Playwright Migration</a:t>
             </a:r>
             <a:endParaRPr lang="en-US" sz="1100"/>
           </a:p>
@@ -8995,7 +8995,7 @@
                 <a:ea typeface="Calibri" pitchFamily="34" charset="-122"/>
                 <a:cs typeface="Calibri" pitchFamily="34" charset="-120"/>
               </a:rPr>
-              <a:t>What happens here + which AI tool / prompt you used</a:t>
+              <a:t>Each Cypress spec + POM converted to Playwright Python BDD: Gherkin .feature file, Python Page Object, pytest-bdd step definitions. Same selectors confirmed once, reused in both frameworks.</a:t>
             </a:r>
             <a:endParaRPr lang="en-US" sz="950"/>
           </a:p>
@@ -9129,7 +9129,7 @@
                 <a:ea typeface="Arial" pitchFamily="34" charset="-122"/>
                 <a:cs typeface="Arial" pitchFamily="34" charset="-120"/>
               </a:rPr>
-              <a:t>Step / Phase</a:t>
+              <a:t>Phase 5 - Execution + Human Review</a:t>
             </a:r>
             <a:endParaRPr lang="en-US" sz="1100"/>
           </a:p>
@@ -9168,7 +9168,7 @@
                 <a:ea typeface="Calibri" pitchFamily="34" charset="-122"/>
                 <a:cs typeface="Calibri" pitchFamily="34" charset="-120"/>
               </a:rPr>
-              <a:t>What happens here + which AI tool / prompt you used</a:t>
+              <a:t>Full suites run headless. Human review caught 3 code bugs. All fixed. 8/8 passing in both frameworks. Bugs documented in docs/ai_review.md and docs/measured_improvement.md.</a:t>
             </a:r>
             <a:endParaRPr lang="en-US" sz="950"/>
           </a:p>
@@ -9371,7 +9371,7 @@
                 <a:ea typeface="Arial" pitchFamily="34" charset="-122"/>
                 <a:cs typeface="Arial" pitchFamily="34" charset="-120"/>
               </a:rPr>
-              <a:t>BEFORE — The Manual Way</a:t>
+              <a:t>BEFORE - Manual Cypress-to-Playwright Migration</a:t>
             </a:r>
             <a:endParaRPr lang="en-US" sz="1400"/>
           </a:p>
@@ -9414,10 +9414,100 @@
                 <a:ea typeface="Calibri" pitchFamily="34" charset="-122"/>
                 <a:cs typeface="Calibri" pitchFamily="34" charset="-120"/>
               </a:rPr>
-              <a:t>Step-by-step manual process</a:t>
+              <a:t>Re-verify every selector in Playwright manually | Rewrite each POM class from TypeScript to Python | Author Gherkin .feature files from scratch | Write pytest-bdd step definitions | Wire conftest fixtures | Estimated time: 2-3 days per suite | Risk: stale selectors, missed steps, credential leaks in code</a:t>
             </a:r>
             <a:endParaRPr lang="en-US" sz="1200"/>
           </a:p>
+        </p:txBody>
+      </p:sp>
+      <p:sp>
+        <p:nvSpPr>
+          <p:cNvPr id="7" name="Shape 4"/>
+          <p:cNvSpPr/>
+          <p:nvPr/>
+        </p:nvSpPr>
+        <p:spPr>
+          <a:xfrm>
+            <a:off x="4709160" y="1097280"/>
+            <a:ext cx="3977640" cy="457200"/>
+          </a:xfrm>
+          <a:prstGeom prst="roundRect">
+            <a:avLst>
+              <a:gd name="adj" fmla="val 10000"/>
+            </a:avLst>
+          </a:prstGeom>
+          <a:solidFill>
+            <a:srgbClr val="075056"/>
+          </a:solidFill>
+          <a:ln/>
+        </p:spPr>
+        <p:txBody>
+          <a:bodyPr/>
+          <a:lstStyle/>
+          <a:p>
+            <a:endParaRPr lang="en-US"/>
+          </a:p>
+        </p:txBody>
+      </p:sp>
+      <p:sp>
+        <p:nvSpPr>
+          <p:cNvPr id="8" name="Text 5"/>
+          <p:cNvSpPr/>
+          <p:nvPr/>
+        </p:nvSpPr>
+        <p:spPr>
+          <a:xfrm>
+            <a:off x="4709160" y="1097280"/>
+            <a:ext cx="3977640" cy="457200"/>
+          </a:xfrm>
+          <a:prstGeom prst="rect">
+            <a:avLst/>
+          </a:prstGeom>
+          <a:noFill/>
+          <a:ln/>
+        </p:spPr>
+        <p:txBody>
+          <a:bodyPr wrap="square" rtlCol="0" anchor="ctr"/>
+          <a:lstStyle/>
+          <a:p>
+            <a:pPr marL="0" indent="0" algn="ctr">
+              <a:buNone/>
+            </a:pPr>
+            <a:r>
+              <a:rPr lang="en-US" sz="1400" b="1">
+                <a:solidFill>
+                  <a:srgbClr val="FFFFFF"/>
+                </a:solidFill>
+                <a:latin typeface="Arial" pitchFamily="34" charset="0"/>
+                <a:ea typeface="Arial" pitchFamily="34" charset="-122"/>
+                <a:cs typeface="Arial" pitchFamily="34" charset="-120"/>
+              </a:rPr>
+              <a:t>AFTER - Agent-Driven Migration</a:t>
+            </a:r>
+            <a:endParaRPr lang="en-US" sz="1400"/>
+          </a:p>
+        </p:txBody>
+      </p:sp>
+      <p:sp>
+        <p:nvSpPr>
+          <p:cNvPr id="9" name="Text 6"/>
+          <p:cNvSpPr/>
+          <p:nvPr/>
+        </p:nvSpPr>
+        <p:spPr>
+          <a:xfrm>
+            <a:off x="4800600" y="1691640"/>
+            <a:ext cx="3794760" cy="2926080"/>
+          </a:xfrm>
+          <a:prstGeom prst="rect">
+            <a:avLst/>
+          </a:prstGeom>
+          <a:noFill/>
+          <a:ln/>
+        </p:spPr>
+        <p:txBody>
+          <a:bodyPr wrap="square" rtlCol="0" anchor="t"/>
+          <a:lstStyle/>
           <a:p>
             <a:pPr marL="152400" indent="-152400">
               <a:spcAft>
@@ -9435,223 +9525,7 @@
                 <a:ea typeface="Calibri" pitchFamily="34" charset="-122"/>
                 <a:cs typeface="Calibri" pitchFamily="34" charset="-120"/>
               </a:rPr>
-              <a:t>Time taken (hrs / min)</a:t>
-            </a:r>
-            <a:endParaRPr lang="en-US" sz="1200"/>
-          </a:p>
-          <a:p>
-            <a:pPr marL="152400" indent="-152400">
-              <a:spcAft>
-                <a:spcPts val="600"/>
-              </a:spcAft>
-              <a:buSzPct val="100000"/>
-              <a:buChar char="•"/>
-            </a:pPr>
-            <a:r>
-              <a:rPr lang="en-US" sz="1200">
-                <a:solidFill>
-                  <a:srgbClr val="1B2227"/>
-                </a:solidFill>
-                <a:latin typeface="Calibri" pitchFamily="34" charset="0"/>
-                <a:ea typeface="Calibri" pitchFamily="34" charset="-122"/>
-                <a:cs typeface="Calibri" pitchFamily="34" charset="-120"/>
-              </a:rPr>
-              <a:t>Pain points &amp; error risks</a:t>
-            </a:r>
-            <a:endParaRPr lang="en-US" sz="1200"/>
-          </a:p>
-          <a:p>
-            <a:pPr marL="152400" indent="-152400">
-              <a:spcAft>
-                <a:spcPts val="600"/>
-              </a:spcAft>
-              <a:buSzPct val="100000"/>
-              <a:buChar char="•"/>
-            </a:pPr>
-            <a:r>
-              <a:rPr lang="en-US" sz="1200">
-                <a:solidFill>
-                  <a:srgbClr val="1B2227"/>
-                </a:solidFill>
-                <a:latin typeface="Calibri" pitchFamily="34" charset="0"/>
-                <a:ea typeface="Calibri" pitchFamily="34" charset="-122"/>
-                <a:cs typeface="Calibri" pitchFamily="34" charset="-120"/>
-              </a:rPr>
-              <a:t>Quality issues that occurred</a:t>
-            </a:r>
-            <a:endParaRPr lang="en-US" sz="1200"/>
-          </a:p>
-        </p:txBody>
-      </p:sp>
-      <p:sp>
-        <p:nvSpPr>
-          <p:cNvPr id="7" name="Shape 4"/>
-          <p:cNvSpPr/>
-          <p:nvPr/>
-        </p:nvSpPr>
-        <p:spPr>
-          <a:xfrm>
-            <a:off x="4709160" y="1097280"/>
-            <a:ext cx="3977640" cy="457200"/>
-          </a:xfrm>
-          <a:prstGeom prst="roundRect">
-            <a:avLst>
-              <a:gd name="adj" fmla="val 10000"/>
-            </a:avLst>
-          </a:prstGeom>
-          <a:solidFill>
-            <a:srgbClr val="075056"/>
-          </a:solidFill>
-          <a:ln/>
-        </p:spPr>
-        <p:txBody>
-          <a:bodyPr/>
-          <a:lstStyle/>
-          <a:p>
-            <a:endParaRPr lang="en-US"/>
-          </a:p>
-        </p:txBody>
-      </p:sp>
-      <p:sp>
-        <p:nvSpPr>
-          <p:cNvPr id="8" name="Text 5"/>
-          <p:cNvSpPr/>
-          <p:nvPr/>
-        </p:nvSpPr>
-        <p:spPr>
-          <a:xfrm>
-            <a:off x="4709160" y="1097280"/>
-            <a:ext cx="3977640" cy="457200"/>
-          </a:xfrm>
-          <a:prstGeom prst="rect">
-            <a:avLst/>
-          </a:prstGeom>
-          <a:noFill/>
-          <a:ln/>
-        </p:spPr>
-        <p:txBody>
-          <a:bodyPr wrap="square" rtlCol="0" anchor="ctr"/>
-          <a:lstStyle/>
-          <a:p>
-            <a:pPr marL="0" indent="0" algn="ctr">
-              <a:buNone/>
-            </a:pPr>
-            <a:r>
-              <a:rPr lang="en-US" sz="1400" b="1">
-                <a:solidFill>
-                  <a:srgbClr val="FFFFFF"/>
-                </a:solidFill>
-                <a:latin typeface="Arial" pitchFamily="34" charset="0"/>
-                <a:ea typeface="Arial" pitchFamily="34" charset="-122"/>
-                <a:cs typeface="Arial" pitchFamily="34" charset="-120"/>
-              </a:rPr>
-              <a:t>AFTER — The AI-Assisted Way</a:t>
-            </a:r>
-            <a:endParaRPr lang="en-US" sz="1400"/>
-          </a:p>
-        </p:txBody>
-      </p:sp>
-      <p:sp>
-        <p:nvSpPr>
-          <p:cNvPr id="9" name="Text 6"/>
-          <p:cNvSpPr/>
-          <p:nvPr/>
-        </p:nvSpPr>
-        <p:spPr>
-          <a:xfrm>
-            <a:off x="4800600" y="1691640"/>
-            <a:ext cx="3794760" cy="2926080"/>
-          </a:xfrm>
-          <a:prstGeom prst="rect">
-            <a:avLst/>
-          </a:prstGeom>
-          <a:noFill/>
-          <a:ln/>
-        </p:spPr>
-        <p:txBody>
-          <a:bodyPr wrap="square" rtlCol="0" anchor="t"/>
-          <a:lstStyle/>
-          <a:p>
-            <a:pPr marL="152400" indent="-152400">
-              <a:spcAft>
-                <a:spcPts val="600"/>
-              </a:spcAft>
-              <a:buSzPct val="100000"/>
-              <a:buChar char="•"/>
-            </a:pPr>
-            <a:r>
-              <a:rPr lang="en-US" sz="1200">
-                <a:solidFill>
-                  <a:srgbClr val="1B2227"/>
-                </a:solidFill>
-                <a:latin typeface="Calibri" pitchFamily="34" charset="0"/>
-                <a:ea typeface="Calibri" pitchFamily="34" charset="-122"/>
-                <a:cs typeface="Calibri" pitchFamily="34" charset="-120"/>
-              </a:rPr>
-              <a:t>Key AI steps / prompts used</a:t>
-            </a:r>
-            <a:endParaRPr lang="en-US" sz="1200"/>
-          </a:p>
-          <a:p>
-            <a:pPr marL="152400" indent="-152400">
-              <a:spcAft>
-                <a:spcPts val="600"/>
-              </a:spcAft>
-              <a:buSzPct val="100000"/>
-              <a:buChar char="•"/>
-            </a:pPr>
-            <a:r>
-              <a:rPr lang="en-US" sz="1200">
-                <a:solidFill>
-                  <a:srgbClr val="1B2227"/>
-                </a:solidFill>
-                <a:latin typeface="Calibri" pitchFamily="34" charset="0"/>
-                <a:ea typeface="Calibri" pitchFamily="34" charset="-122"/>
-                <a:cs typeface="Calibri" pitchFamily="34" charset="-120"/>
-              </a:rPr>
-              <a:t>How you refined the output (rounds)</a:t>
-            </a:r>
-            <a:endParaRPr lang="en-US" sz="1200"/>
-          </a:p>
-          <a:p>
-            <a:pPr marL="152400" indent="-152400">
-              <a:spcAft>
-                <a:spcPts val="600"/>
-              </a:spcAft>
-              <a:buSzPct val="100000"/>
-              <a:buChar char="•"/>
-            </a:pPr>
-            <a:r>
-              <a:rPr lang="en-US" sz="1200">
-                <a:solidFill>
-                  <a:srgbClr val="1B2227"/>
-                </a:solidFill>
-                <a:latin typeface="Calibri" pitchFamily="34" charset="0"/>
-                <a:ea typeface="Calibri" pitchFamily="34" charset="-122"/>
-                <a:cs typeface="Calibri" pitchFamily="34" charset="-120"/>
-              </a:rPr>
-              <a:t>First-pass accuracy (e.g. ~90%)</a:t>
-            </a:r>
-            <a:endParaRPr lang="en-US" sz="1200"/>
-          </a:p>
-          <a:p>
-            <a:pPr marL="152400" indent="-152400">
-              <a:spcAft>
-                <a:spcPts val="600"/>
-              </a:spcAft>
-              <a:buSzPct val="100000"/>
-              <a:buChar char="•"/>
-            </a:pPr>
-            <a:r>
-              <a:rPr lang="en-US" sz="1200">
-                <a:solidFill>
-                  <a:srgbClr val="1B2227"/>
-                </a:solidFill>
-                <a:latin typeface="Calibri" pitchFamily="34" charset="0"/>
-                <a:ea typeface="Calibri" pitchFamily="34" charset="-122"/>
-                <a:cs typeface="Calibri" pitchFamily="34" charset="-120"/>
-              </a:rPr>
-              <a:t>Time taken with AI — compare</a:t>
+              <a:t>Agent explores live app via MCP Playwright - real selectors, one pass | Generates Cypress TS suite from requirements doc | Migrates to Playwright Python BDD automatically | Human reviews output, catches 3 bugs, runs suite | Total time: ~7h end-to-end | First-pass: 6/8 tests passing before any manual fix | Final: 8/8 passing after 3 targeted fixes</a:t>
             </a:r>
             <a:endParaRPr lang="en-US" sz="1200"/>
           </a:p>
@@ -11589,7 +11463,7 @@
                 <a:ea typeface="Calibri" pitchFamily="34" charset="-122"/>
                 <a:cs typeface="Calibri" pitchFamily="34" charset="-120"/>
               </a:rPr>
-              <a:t>[ 1–2 sentences: overall time saved, quality gain, and team benefit — be specific with numbers. ]</a:t>
+              <a:t>2-3 days of manual migration compressed to a 7-hour agent session. 8/8 tests passing in both Cypress (TypeScript) and Playwright (Python BDD). 3 code bugs caught and fixed during human review - none introduced regressions. Workflow fully documented and reusable: point the agent at a new requirements doc and repeat. Estimated reuse value: 15-20 hours saved per future migration engagement.</a:t>
             </a:r>
             <a:endParaRPr lang="en-US" sz="1100"/>
           </a:p>
@@ -11858,7 +11732,7 @@
                 <a:ea typeface="Calibri" pitchFamily="34" charset="-122"/>
                 <a:cs typeface="Calibri" pitchFamily="34" charset="-120"/>
               </a:rPr>
-              <a:t>The asset others can pick up — a prompt library, skill, MCP server, template, or pattern.</a:t>
+              <a:t>.claude/skills/cypress-test-gen.md (Phase 1 skill) and .claude/agents/playwright-migration.md (Phase 2 agent). CLAUDE.md encodes all project conventions. migration_workflow.md documents the full conversion pattern library.</a:t>
             </a:r>
             <a:endParaRPr lang="en-US" sz="1150"/>
           </a:p>
@@ -12031,7 +11905,7 @@
                 <a:ea typeface="Calibri" pitchFamily="34" charset="-122"/>
                 <a:cs typeface="Calibri" pitchFamily="34" charset="-120"/>
               </a:rPr>
-              <a:t>Which teams, accounts, or roles could use this as-is or with small changes?</a:t>
+              <a:t>Any QA engineer on a Cypress-to-Playwright migration engagement. Works for any web app with a requirements document - point the agent at a new target app and repeat the same workflow.</a:t>
             </a:r>
             <a:endParaRPr lang="en-US" sz="1150"/>
           </a:p>
@@ -12204,7 +12078,7 @@
                 <a:ea typeface="Calibri" pitchFamily="34" charset="-122"/>
                 <a:cs typeface="Calibri" pitchFamily="34" charset="-120"/>
               </a:rPr>
-              <a:t>Docs, README, repo link, or demo that lets someone else run it.</a:t>
+              <a:t>GitHub repo (feature/migration-progress) with requirements/, cypress/, playwright/, reports/, docs/. README documents the full workflow. All prompts versioned in .claude/.</a:t>
             </a:r>
             <a:endParaRPr lang="en-US" sz="1150"/>
           </a:p>
@@ -12377,7 +12251,7 @@
                 <a:ea typeface="Calibri" pitchFamily="34" charset="-122"/>
                 <a:cs typeface="Calibri" pitchFamily="34" charset="-120"/>
               </a:rPr>
-              <a:t>If adopted widely, what changes — hours saved, risk reduced, capability unlocked?</a:t>
+              <a:t>One reusable workflow eliminates 2-3 days of manual work per migration. Applied across 5 engagements per year = 100-150 hours of engineering time redirected to exploratory QA and new coverage.</a:t>
             </a:r>
             <a:endParaRPr lang="en-US" sz="1150"/>
           </a:p>
@@ -12608,10 +12482,127 @@
                 <a:ea typeface="Calibri" pitchFamily="34" charset="-122"/>
                 <a:cs typeface="Calibri" pitchFamily="34" charset="-120"/>
               </a:rPr>
-              <a:t>Capability it handled well — cite a real example</a:t>
+              <a:t>Selector mapping via MCP Playwright: captured real, working selectors for all 7 requirements in one exploration pass - zero stale locators in generated output. Full POM + BDD structure: generated TypeScript and Python Page Objects, Gherkin .feature files, and pytest-bdd step defs following all CLAUDE.md conventions without deviation.</a:t>
             </a:r>
             <a:endParaRPr lang="en-US" sz="1150"/>
           </a:p>
+        </p:txBody>
+      </p:sp>
+      <p:sp>
+        <p:nvSpPr>
+          <p:cNvPr id="8" name="Shape 5"/>
+          <p:cNvSpPr/>
+          <p:nvPr/>
+        </p:nvSpPr>
+        <p:spPr>
+          <a:xfrm>
+            <a:off x="457200" y="2350008"/>
+            <a:ext cx="8229600" cy="1051560"/>
+          </a:xfrm>
+          <a:prstGeom prst="roundRect">
+            <a:avLst>
+              <a:gd name="adj" fmla="val 4348"/>
+            </a:avLst>
+          </a:prstGeom>
+          <a:solidFill>
+            <a:srgbClr val="DFE7ED"/>
+          </a:solidFill>
+          <a:ln/>
+        </p:spPr>
+        <p:txBody>
+          <a:bodyPr/>
+          <a:lstStyle/>
+          <a:p>
+            <a:endParaRPr lang="en-US"/>
+          </a:p>
+        </p:txBody>
+      </p:sp>
+      <p:sp>
+        <p:nvSpPr>
+          <p:cNvPr id="9" name="Shape 6"/>
+          <p:cNvSpPr/>
+          <p:nvPr/>
+        </p:nvSpPr>
+        <p:spPr>
+          <a:xfrm>
+            <a:off x="621792" y="2670048"/>
+            <a:ext cx="411480" cy="411480"/>
+          </a:xfrm>
+          <a:prstGeom prst="ellipse">
+            <a:avLst/>
+          </a:prstGeom>
+          <a:solidFill>
+            <a:srgbClr val="FE3A39"/>
+          </a:solidFill>
+          <a:ln/>
+        </p:spPr>
+        <p:txBody>
+          <a:bodyPr/>
+          <a:lstStyle/>
+          <a:p>
+            <a:endParaRPr lang="en-US"/>
+          </a:p>
+        </p:txBody>
+      </p:sp>
+      <p:sp>
+        <p:nvSpPr>
+          <p:cNvPr id="10" name="Text 7"/>
+          <p:cNvSpPr/>
+          <p:nvPr/>
+        </p:nvSpPr>
+        <p:spPr>
+          <a:xfrm>
+            <a:off x="1188720" y="2441448"/>
+            <a:ext cx="7315200" cy="365760"/>
+          </a:xfrm>
+          <a:prstGeom prst="rect">
+            <a:avLst/>
+          </a:prstGeom>
+          <a:noFill/>
+          <a:ln/>
+        </p:spPr>
+        <p:txBody>
+          <a:bodyPr wrap="square" rtlCol="0" anchor="ctr"/>
+          <a:lstStyle/>
+          <a:p>
+            <a:pPr marL="0" indent="0">
+              <a:buNone/>
+            </a:pPr>
+            <a:r>
+              <a:rPr lang="en-US" sz="1400" b="1">
+                <a:solidFill>
+                  <a:srgbClr val="FE3A39"/>
+                </a:solidFill>
+                <a:latin typeface="Arial" pitchFamily="34" charset="0"/>
+                <a:ea typeface="Arial" pitchFamily="34" charset="-122"/>
+                <a:cs typeface="Arial" pitchFamily="34" charset="-120"/>
+              </a:rPr>
+              <a:t>What AI got WRONG</a:t>
+            </a:r>
+            <a:endParaRPr lang="en-US" sz="1400"/>
+          </a:p>
+        </p:txBody>
+      </p:sp>
+      <p:sp>
+        <p:nvSpPr>
+          <p:cNvPr id="11" name="Text 8"/>
+          <p:cNvSpPr/>
+          <p:nvPr/>
+        </p:nvSpPr>
+        <p:spPr>
+          <a:xfrm>
+            <a:off x="1188720" y="2807208"/>
+            <a:ext cx="7223760" cy="548640"/>
+          </a:xfrm>
+          <a:prstGeom prst="rect">
+            <a:avLst/>
+          </a:prstGeom>
+          <a:noFill/>
+          <a:ln/>
+        </p:spPr>
+        <p:txBody>
+          <a:bodyPr wrap="square" rtlCol="0" anchor="ctr"/>
+          <a:lstStyle/>
           <a:p>
             <a:pPr marL="152400" indent="-152400">
               <a:buSzPct val="100000"/>
@@ -12626,7 +12617,7 @@
                 <a:ea typeface="Calibri" pitchFamily="34" charset="-122"/>
                 <a:cs typeface="Calibri" pitchFamily="34" charset="-120"/>
               </a:rPr>
-              <a:t>Another strength from your actual work</a:t>
+              <a:t>Fixed sleep in autocomplete (employee_list_page.py line 16): wait_for_timeout(800) worked during exploration but failed silently on slow networks - test passed for the wrong reason. Wrong .within() target: cy.within() called on 2 [role="dialog"] elements - agent did not anticipate nested dialog structure. Wrong assertion for disabled input: cy.contains(input[disabled], value) does not match input value attribute.</a:t>
             </a:r>
             <a:endParaRPr lang="en-US" sz="1150"/>
           </a:p>
@@ -12634,13 +12625,13 @@
       </p:sp>
       <p:sp>
         <p:nvSpPr>
-          <p:cNvPr id="8" name="Shape 5"/>
-          <p:cNvSpPr/>
-          <p:nvPr/>
-        </p:nvSpPr>
-        <p:spPr>
-          <a:xfrm>
-            <a:off x="457200" y="2350008"/>
+          <p:cNvPr id="12" name="Shape 9"/>
+          <p:cNvSpPr/>
+          <p:nvPr/>
+        </p:nvSpPr>
+        <p:spPr>
+          <a:xfrm>
+            <a:off x="457200" y="3557016"/>
             <a:ext cx="8229600" cy="1051560"/>
           </a:xfrm>
           <a:prstGeom prst="roundRect">
@@ -12663,20 +12654,20 @@
       </p:sp>
       <p:sp>
         <p:nvSpPr>
-          <p:cNvPr id="9" name="Shape 6"/>
-          <p:cNvSpPr/>
-          <p:nvPr/>
-        </p:nvSpPr>
-        <p:spPr>
-          <a:xfrm>
-            <a:off x="621792" y="2670048"/>
+          <p:cNvPr id="13" name="Shape 10"/>
+          <p:cNvSpPr/>
+          <p:nvPr/>
+        </p:nvSpPr>
+        <p:spPr>
+          <a:xfrm>
+            <a:off x="621792" y="3877056"/>
             <a:ext cx="411480" cy="411480"/>
           </a:xfrm>
           <a:prstGeom prst="ellipse">
             <a:avLst/>
           </a:prstGeom>
           <a:solidFill>
-            <a:srgbClr val="FE3A39"/>
+            <a:srgbClr val="024879"/>
           </a:solidFill>
           <a:ln/>
         </p:spPr>
@@ -12690,13 +12681,13 @@
       </p:sp>
       <p:sp>
         <p:nvSpPr>
-          <p:cNvPr id="10" name="Text 7"/>
-          <p:cNvSpPr/>
-          <p:nvPr/>
-        </p:nvSpPr>
-        <p:spPr>
-          <a:xfrm>
-            <a:off x="1188720" y="2441448"/>
+          <p:cNvPr id="14" name="Text 11"/>
+          <p:cNvSpPr/>
+          <p:nvPr/>
+        </p:nvSpPr>
+        <p:spPr>
+          <a:xfrm>
+            <a:off x="1188720" y="3648456"/>
             <a:ext cx="7315200" cy="365760"/>
           </a:xfrm>
           <a:prstGeom prst="rect">
@@ -12715,13 +12706,13 @@
             <a:r>
               <a:rPr lang="en-US" sz="1400" b="1">
                 <a:solidFill>
-                  <a:srgbClr val="FE3A39"/>
+                  <a:srgbClr val="024879"/>
                 </a:solidFill>
                 <a:latin typeface="Arial" pitchFamily="34" charset="0"/>
                 <a:ea typeface="Arial" pitchFamily="34" charset="-122"/>
                 <a:cs typeface="Arial" pitchFamily="34" charset="-120"/>
               </a:rPr>
-              <a:t>What AI got WRONG</a:t>
+              <a:t>What I corrected manually</a:t>
             </a:r>
             <a:endParaRPr lang="en-US" sz="1400"/>
           </a:p>
@@ -12729,13 +12720,13 @@
       </p:sp>
       <p:sp>
         <p:nvSpPr>
-          <p:cNvPr id="11" name="Text 8"/>
-          <p:cNvSpPr/>
-          <p:nvPr/>
-        </p:nvSpPr>
-        <p:spPr>
-          <a:xfrm>
-            <a:off x="1188720" y="2807208"/>
+          <p:cNvPr id="15" name="Text 12"/>
+          <p:cNvSpPr/>
+          <p:nvPr/>
+        </p:nvSpPr>
+        <p:spPr>
+          <a:xfrm>
+            <a:off x="1188720" y="4014216"/>
             <a:ext cx="7223760" cy="548640"/>
           </a:xfrm>
           <a:prstGeom prst="rect">
@@ -12761,178 +12752,7 @@
                 <a:ea typeface="Calibri" pitchFamily="34" charset="-122"/>
                 <a:cs typeface="Calibri" pitchFamily="34" charset="-120"/>
               </a:rPr>
-              <a:t>A specific failure or limitation</a:t>
-            </a:r>
-            <a:endParaRPr lang="en-US" sz="1150"/>
-          </a:p>
-          <a:p>
-            <a:pPr marL="152400" indent="-152400">
-              <a:buSzPct val="100000"/>
-              <a:buChar char="•"/>
-            </a:pPr>
-            <a:r>
-              <a:rPr lang="en-US" sz="1150">
-                <a:solidFill>
-                  <a:srgbClr val="1B2227"/>
-                </a:solidFill>
-                <a:latin typeface="Calibri" pitchFamily="34" charset="0"/>
-                <a:ea typeface="Calibri" pitchFamily="34" charset="-122"/>
-                <a:cs typeface="Calibri" pitchFamily="34" charset="-120"/>
-              </a:rPr>
-              <a:t>What triggered it — prompt, data, or tool limit?</a:t>
-            </a:r>
-            <a:endParaRPr lang="en-US" sz="1150"/>
-          </a:p>
-        </p:txBody>
-      </p:sp>
-      <p:sp>
-        <p:nvSpPr>
-          <p:cNvPr id="12" name="Shape 9"/>
-          <p:cNvSpPr/>
-          <p:nvPr/>
-        </p:nvSpPr>
-        <p:spPr>
-          <a:xfrm>
-            <a:off x="457200" y="3557016"/>
-            <a:ext cx="8229600" cy="1051560"/>
-          </a:xfrm>
-          <a:prstGeom prst="roundRect">
-            <a:avLst>
-              <a:gd name="adj" fmla="val 4348"/>
-            </a:avLst>
-          </a:prstGeom>
-          <a:solidFill>
-            <a:srgbClr val="DFE7ED"/>
-          </a:solidFill>
-          <a:ln/>
-        </p:spPr>
-        <p:txBody>
-          <a:bodyPr/>
-          <a:lstStyle/>
-          <a:p>
-            <a:endParaRPr lang="en-US"/>
-          </a:p>
-        </p:txBody>
-      </p:sp>
-      <p:sp>
-        <p:nvSpPr>
-          <p:cNvPr id="13" name="Shape 10"/>
-          <p:cNvSpPr/>
-          <p:nvPr/>
-        </p:nvSpPr>
-        <p:spPr>
-          <a:xfrm>
-            <a:off x="621792" y="3877056"/>
-            <a:ext cx="411480" cy="411480"/>
-          </a:xfrm>
-          <a:prstGeom prst="ellipse">
-            <a:avLst/>
-          </a:prstGeom>
-          <a:solidFill>
-            <a:srgbClr val="024879"/>
-          </a:solidFill>
-          <a:ln/>
-        </p:spPr>
-        <p:txBody>
-          <a:bodyPr/>
-          <a:lstStyle/>
-          <a:p>
-            <a:endParaRPr lang="en-US"/>
-          </a:p>
-        </p:txBody>
-      </p:sp>
-      <p:sp>
-        <p:nvSpPr>
-          <p:cNvPr id="14" name="Text 11"/>
-          <p:cNvSpPr/>
-          <p:nvPr/>
-        </p:nvSpPr>
-        <p:spPr>
-          <a:xfrm>
-            <a:off x="1188720" y="3648456"/>
-            <a:ext cx="7315200" cy="365760"/>
-          </a:xfrm>
-          <a:prstGeom prst="rect">
-            <a:avLst/>
-          </a:prstGeom>
-          <a:noFill/>
-          <a:ln/>
-        </p:spPr>
-        <p:txBody>
-          <a:bodyPr wrap="square" rtlCol="0" anchor="ctr"/>
-          <a:lstStyle/>
-          <a:p>
-            <a:pPr marL="0" indent="0">
-              <a:buNone/>
-            </a:pPr>
-            <a:r>
-              <a:rPr lang="en-US" sz="1400" b="1">
-                <a:solidFill>
-                  <a:srgbClr val="024879"/>
-                </a:solidFill>
-                <a:latin typeface="Arial" pitchFamily="34" charset="0"/>
-                <a:ea typeface="Arial" pitchFamily="34" charset="-122"/>
-                <a:cs typeface="Arial" pitchFamily="34" charset="-120"/>
-              </a:rPr>
-              <a:t>What I corrected manually</a:t>
-            </a:r>
-            <a:endParaRPr lang="en-US" sz="1400"/>
-          </a:p>
-        </p:txBody>
-      </p:sp>
-      <p:sp>
-        <p:nvSpPr>
-          <p:cNvPr id="15" name="Text 12"/>
-          <p:cNvSpPr/>
-          <p:nvPr/>
-        </p:nvSpPr>
-        <p:spPr>
-          <a:xfrm>
-            <a:off x="1188720" y="4014216"/>
-            <a:ext cx="7223760" cy="548640"/>
-          </a:xfrm>
-          <a:prstGeom prst="rect">
-            <a:avLst/>
-          </a:prstGeom>
-          <a:noFill/>
-          <a:ln/>
-        </p:spPr>
-        <p:txBody>
-          <a:bodyPr wrap="square" rtlCol="0" anchor="ctr"/>
-          <a:lstStyle/>
-          <a:p>
-            <a:pPr marL="152400" indent="-152400">
-              <a:buSzPct val="100000"/>
-              <a:buChar char="•"/>
-            </a:pPr>
-            <a:r>
-              <a:rPr lang="en-US" sz="1150">
-                <a:solidFill>
-                  <a:srgbClr val="1B2227"/>
-                </a:solidFill>
-                <a:latin typeface="Calibri" pitchFamily="34" charset="0"/>
-                <a:ea typeface="Calibri" pitchFamily="34" charset="-122"/>
-                <a:cs typeface="Calibri" pitchFamily="34" charset="-120"/>
-              </a:rPr>
-              <a:t>Where human judgement was required</a:t>
-            </a:r>
-            <a:endParaRPr lang="en-US" sz="1150"/>
-          </a:p>
-          <a:p>
-            <a:pPr marL="152400" indent="-152400">
-              <a:buSzPct val="100000"/>
-              <a:buChar char="•"/>
-            </a:pPr>
-            <a:r>
-              <a:rPr lang="en-US" sz="1150">
-                <a:solidFill>
-                  <a:srgbClr val="1B2227"/>
-                </a:solidFill>
-                <a:latin typeface="Calibri" pitchFamily="34" charset="0"/>
-                <a:ea typeface="Calibri" pitchFamily="34" charset="-122"/>
-                <a:cs typeface="Calibri" pitchFamily="34" charset="-120"/>
-              </a:rPr>
-              <a:t>This shows your critical thinking — be honest</a:t>
+              <a:t>Replaced fixed sleep with wait_for_selector + name filter (docs/measured_improvement.md). Added .last() to both cy.within() calls. Replaced cy.contains(input[disabled]) with .should() callback that iterates all disabled inputs and checks values.</a:t>
             </a:r>
             <a:endParaRPr lang="en-US" sz="1150"/>
           </a:p>
@@ -13179,7 +12999,7 @@
                 <a:ea typeface="Calibri" pitchFamily="34" charset="-122"/>
                 <a:cs typeface="Calibri" pitchFamily="34" charset="-120"/>
               </a:rPr>
-              <a:t>[ paste link ]</a:t>
+              <a:t>github.com/ajulian35/migration-cypress-to-playwright  branch: feature/migration-progress</a:t>
             </a:r>
             <a:endParaRPr lang="en-US" sz="1100"/>
           </a:p>
@@ -13291,7 +13111,7 @@
                 <a:ea typeface="Calibri" pitchFamily="34" charset="-122"/>
                 <a:cs typeface="Calibri" pitchFamily="34" charset="-120"/>
               </a:rPr>
-              <a:t>[ paste link ]</a:t>
+              <a:t>docs/AI_Capstone_Template_L1 op 4.pptx | reports/cypress/ (mochawesome HTML) | reports/playwright/report.html</a:t>
             </a:r>
             <a:endParaRPr lang="en-US" sz="1100"/>
           </a:p>
@@ -13403,7 +13223,7 @@
                 <a:ea typeface="Calibri" pitchFamily="34" charset="-122"/>
                 <a:cs typeface="Calibri" pitchFamily="34" charset="-120"/>
               </a:rPr>
-              <a:t>[ paste link ]</a:t>
+              <a:t>.claude/skills/cypress-test-gen.md | .claude/agents/playwright-migration.md | migration_workflow.md</a:t>
             </a:r>
             <a:endParaRPr lang="en-US" sz="1100"/>
           </a:p>
@@ -13515,7 +13335,7 @@
                 <a:ea typeface="Calibri" pitchFamily="34" charset="-122"/>
                 <a:cs typeface="Calibri" pitchFamily="34" charset="-120"/>
               </a:rPr>
-              <a:t>[ paste link ]</a:t>
+              <a:t>docs/ai_review.md | docs/failure_analysis.md | docs/measured_improvement.md | docs/claude_md_evidence.md | docs/declared_effort.md</a:t>
             </a:r>
             <a:endParaRPr lang="en-US" sz="1100"/>
           </a:p>

</xml_diff>